<commit_message>
Update presentation slides to reflect latest strategic messaging and visuals
Synchronizes HTML, PPTX, and PDF versions of the investor pitch deck with updated headlines, a three-image strip on slide 8, and refined copy on slide 11, while also adjusting asset metadata and build scripts.

Replit-Commit-Author: Agent
Replit-Commit-Session-Id: 85f09f3c-352d-446d-b98e-3f307c26fc5a
Replit-Commit-Checkpoint-Type: full_checkpoint
Replit-Commit-Event-Id: 07338390-b3b3-40b1-9e33-368763de6ce0
Replit-Commit-Screenshot-Url: https://storage.googleapis.com/screenshot-production-us-central1/3bd53afc-ff4f-401b-9e3d-b367791ef629/85f09f3c-352d-446d-b98e-3f307c26fc5a/Dqn5MU0
Replit-Helium-Checkpoint-Created: true
</commit_message>
<xml_diff>
--- a/attached_assets/VaughnMartin-Investor-Pitch-Deck.pptx
+++ b/attached_assets/VaughnMartin-Investor-Pitch-Deck.pptx
@@ -3173,13 +3173,13 @@
           <a:p>
             <a:pPr algn="ctr"/>
             <a:r>
-              <a:rPr sz="4000" b="1">
+              <a:rPr sz="3800" b="1">
                 <a:solidFill>
                   <a:srgbClr val="FFFFFF"/>
                 </a:solidFill>
                 <a:latin typeface="Cormorant Garamond"/>
               </a:rPr>
-              <a:t>When a strategic trigger fires—</a:t>
+              <a:t>When a strategic trigger fires in your organization—</a:t>
             </a:r>
           </a:p>
         </p:txBody>
@@ -3214,7 +3214,7 @@
                 </a:solidFill>
                 <a:latin typeface="Cormorant Garamond"/>
               </a:rPr>
-              <a:t>how long does it take to mobilize a coordinated response?</a:t>
+              <a:t>are you executing in 12 minutes or organizing from scratch?</a:t>
             </a:r>
           </a:p>
         </p:txBody>
@@ -4750,7 +4750,7 @@
                 </a:solidFill>
                 <a:latin typeface="Barlow"/>
               </a:rPr>
-              <a:t>No preparation infrastructure exists. Strategic triggers arrive in real time — the mobilization cycle still averages 30 days.</a:t>
+              <a:t>Enterprises detect more signals, but still mobilize too slowly.</a:t>
             </a:r>
           </a:p>
         </p:txBody>
@@ -4906,7 +4906,7 @@
                 </a:solidFill>
                 <a:latin typeface="Barlow"/>
               </a:rPr>
-              <a:t>We rebuilt the operating model. Pre-staged execution replaces real-time coordination — 12 minutes, not 30 days.</a:t>
+              <a:t>Readiness OS pre-stages response so executives authorize in minutes.</a:t>
             </a:r>
           </a:p>
         </p:txBody>
@@ -5027,7 +5027,7 @@
                 </a:solidFill>
                 <a:latin typeface="Barlow Condensed"/>
               </a:rPr>
-              <a:t>ROI</a:t>
+              <a:t>OUTCOME</a:t>
             </a:r>
           </a:p>
         </p:txBody>
@@ -5062,7 +5062,7 @@
                 </a:solidFill>
                 <a:latin typeface="Barlow"/>
               </a:rPr>
-              <a:t>At $120K, we replace a $400K–$800K retainer. Break-even before the second activation. The budget line already exists.</a:t>
+              <a:t>Earlier detection + faster execution protects value before the window closes.</a:t>
             </a:r>
           </a:p>
         </p:txBody>
@@ -11183,7 +11183,7 @@
       </p:sp>
       <p:pic>
         <p:nvPicPr>
-          <p:cNvPr id="19" name="Picture 18" descr="pptx_command_tower.jpg"/>
+          <p:cNvPr id="19" name="Picture 18" descr="pitch_home.jpg"/>
           <p:cNvPicPr>
             <a:picLocks noChangeAspect="1"/>
           </p:cNvPicPr>
@@ -11197,8 +11197,8 @@
         </p:blipFill>
         <p:spPr>
           <a:xfrm>
-            <a:off x="320040" y="3273552"/>
-            <a:ext cx="5669280" cy="3246120"/>
+            <a:off x="320040" y="3383280"/>
+            <a:ext cx="3758184" cy="2606040"/>
           </a:xfrm>
           <a:prstGeom prst="rect">
             <a:avLst/>
@@ -11213,8 +11213,8 @@
         </p:nvSpPr>
         <p:spPr>
           <a:xfrm>
-            <a:off x="320040" y="3273552"/>
-            <a:ext cx="5669280" cy="3246120"/>
+            <a:off x="320040" y="3383280"/>
+            <a:ext cx="3758184" cy="2606040"/>
           </a:xfrm>
           <a:prstGeom prst="rect">
             <a:avLst/>
@@ -11256,8 +11256,8 @@
         </p:nvSpPr>
         <p:spPr>
           <a:xfrm>
-            <a:off x="320040" y="6199632"/>
-            <a:ext cx="5669280" cy="320040"/>
+            <a:off x="320040" y="5669280"/>
+            <a:ext cx="3758184" cy="320040"/>
           </a:xfrm>
           <a:prstGeom prst="rect">
             <a:avLst/>
@@ -11299,8 +11299,8 @@
         </p:nvSpPr>
         <p:spPr>
           <a:xfrm>
-            <a:off x="429768" y="6275832"/>
-            <a:ext cx="5449824" cy="320040"/>
+            <a:off x="429768" y="5745480"/>
+            <a:ext cx="3538728" cy="320040"/>
           </a:xfrm>
           <a:prstGeom prst="rect">
             <a:avLst/>
@@ -11321,14 +11321,14 @@
                 </a:solidFill>
                 <a:latin typeface="Barlow Condensed"/>
               </a:rPr>
-              <a:t>COMMAND TOWER · 221 TRIGGERS ARMED · 20 ACTIVE DETECTIONS · 170 PROTOCOLS READY</a:t>
+              <a:t>LIVE READINESS EXPERIENCE</a:t>
             </a:r>
           </a:p>
         </p:txBody>
       </p:sp>
       <p:pic>
         <p:nvPicPr>
-          <p:cNvPr id="23" name="Picture 22" descr="pptx_protocols.jpg"/>
+          <p:cNvPr id="23" name="Picture 22" descr="deck_signals.jpg"/>
           <p:cNvPicPr>
             <a:picLocks noChangeAspect="1"/>
           </p:cNvPicPr>
@@ -11342,8 +11342,8 @@
         </p:blipFill>
         <p:spPr>
           <a:xfrm>
-            <a:off x="6199632" y="3273552"/>
-            <a:ext cx="5669280" cy="3246120"/>
+            <a:off x="4325112" y="3383280"/>
+            <a:ext cx="3758184" cy="2606040"/>
           </a:xfrm>
           <a:prstGeom prst="rect">
             <a:avLst/>
@@ -11358,8 +11358,8 @@
         </p:nvSpPr>
         <p:spPr>
           <a:xfrm>
-            <a:off x="6199632" y="3273552"/>
-            <a:ext cx="5669280" cy="3246120"/>
+            <a:off x="4325112" y="3383280"/>
+            <a:ext cx="3758184" cy="2606040"/>
           </a:xfrm>
           <a:prstGeom prst="rect">
             <a:avLst/>
@@ -11401,8 +11401,8 @@
         </p:nvSpPr>
         <p:spPr>
           <a:xfrm>
-            <a:off x="6199632" y="6199632"/>
-            <a:ext cx="5669280" cy="320040"/>
+            <a:off x="4325112" y="5669280"/>
+            <a:ext cx="3758184" cy="320040"/>
           </a:xfrm>
           <a:prstGeom prst="rect">
             <a:avLst/>
@@ -11444,8 +11444,8 @@
         </p:nvSpPr>
         <p:spPr>
           <a:xfrm>
-            <a:off x="6309360" y="6275832"/>
-            <a:ext cx="5449824" cy="320040"/>
+            <a:off x="4434840" y="5745480"/>
+            <a:ext cx="3538728" cy="320040"/>
           </a:xfrm>
           <a:prstGeom prst="rect">
             <a:avLst/>
@@ -11466,14 +11466,159 @@
                 </a:solidFill>
                 <a:latin typeface="Barlow Condensed"/>
               </a:rPr>
-              <a:t>READINESS PROTOCOL LIBRARY · 170 PROTOCOLS · EVERY STRATEGIC SCENARIO COVERED</a:t>
-            </a:r>
-          </a:p>
-        </p:txBody>
-      </p:sp>
-      <p:sp>
-        <p:nvSpPr>
-          <p:cNvPr id="27" name="TextBox 26"/>
+              <a:t>SIGNAL DETECTION FEED</a:t>
+            </a:r>
+          </a:p>
+        </p:txBody>
+      </p:sp>
+      <p:pic>
+        <p:nvPicPr>
+          <p:cNvPr id="27" name="Picture 26" descr="pitch_builder.jpg"/>
+          <p:cNvPicPr>
+            <a:picLocks noChangeAspect="1"/>
+          </p:cNvPicPr>
+          <p:nvPr/>
+        </p:nvPicPr>
+        <p:blipFill>
+          <a:blip r:embed="rId4"/>
+          <a:stretch>
+            <a:fillRect/>
+          </a:stretch>
+        </p:blipFill>
+        <p:spPr>
+          <a:xfrm>
+            <a:off x="8330184" y="3383280"/>
+            <a:ext cx="3758184" cy="2606040"/>
+          </a:xfrm>
+          <a:prstGeom prst="rect">
+            <a:avLst/>
+          </a:prstGeom>
+        </p:spPr>
+      </p:pic>
+      <p:sp>
+        <p:nvSpPr>
+          <p:cNvPr id="28" name="Rectangle 27"/>
+          <p:cNvSpPr/>
+          <p:nvPr/>
+        </p:nvSpPr>
+        <p:spPr>
+          <a:xfrm>
+            <a:off x="8330184" y="3383280"/>
+            <a:ext cx="3758184" cy="2606040"/>
+          </a:xfrm>
+          <a:prstGeom prst="rect">
+            <a:avLst/>
+          </a:prstGeom>
+          <a:noFill/>
+          <a:ln w="15240">
+            <a:solidFill>
+              <a:srgbClr val="C9A84C"/>
+            </a:solidFill>
+          </a:ln>
+        </p:spPr>
+        <p:style>
+          <a:lnRef idx="1">
+            <a:schemeClr val="accent1"/>
+          </a:lnRef>
+          <a:fillRef idx="3">
+            <a:schemeClr val="accent1"/>
+          </a:fillRef>
+          <a:effectRef idx="2">
+            <a:schemeClr val="accent1"/>
+          </a:effectRef>
+          <a:fontRef idx="minor">
+            <a:schemeClr val="lt1"/>
+          </a:fontRef>
+        </p:style>
+        <p:txBody>
+          <a:bodyPr rtlCol="0" anchor="ctr"/>
+          <a:lstStyle/>
+          <a:p>
+            <a:pPr algn="ctr"/>
+          </a:p>
+        </p:txBody>
+      </p:sp>
+      <p:sp>
+        <p:nvSpPr>
+          <p:cNvPr id="29" name="Rectangle 28"/>
+          <p:cNvSpPr/>
+          <p:nvPr/>
+        </p:nvSpPr>
+        <p:spPr>
+          <a:xfrm>
+            <a:off x="8330184" y="5669280"/>
+            <a:ext cx="3758184" cy="320040"/>
+          </a:xfrm>
+          <a:prstGeom prst="rect">
+            <a:avLst/>
+          </a:prstGeom>
+          <a:solidFill>
+            <a:srgbClr val="080D26"/>
+          </a:solidFill>
+          <a:ln>
+            <a:noFill/>
+          </a:ln>
+        </p:spPr>
+        <p:style>
+          <a:lnRef idx="1">
+            <a:schemeClr val="accent1"/>
+          </a:lnRef>
+          <a:fillRef idx="3">
+            <a:schemeClr val="accent1"/>
+          </a:fillRef>
+          <a:effectRef idx="2">
+            <a:schemeClr val="accent1"/>
+          </a:effectRef>
+          <a:fontRef idx="minor">
+            <a:schemeClr val="lt1"/>
+          </a:fontRef>
+        </p:style>
+        <p:txBody>
+          <a:bodyPr rtlCol="0" anchor="ctr"/>
+          <a:lstStyle/>
+          <a:p>
+            <a:pPr algn="ctr"/>
+          </a:p>
+        </p:txBody>
+      </p:sp>
+      <p:sp>
+        <p:nvSpPr>
+          <p:cNvPr id="30" name="TextBox 29"/>
+          <p:cNvSpPr txBox="1"/>
+          <p:nvPr/>
+        </p:nvSpPr>
+        <p:spPr>
+          <a:xfrm>
+            <a:off x="8439912" y="5745480"/>
+            <a:ext cx="3538728" cy="320040"/>
+          </a:xfrm>
+          <a:prstGeom prst="rect">
+            <a:avLst/>
+          </a:prstGeom>
+          <a:noFill/>
+        </p:spPr>
+        <p:txBody>
+          <a:bodyPr wrap="square">
+            <a:spAutoFit/>
+          </a:bodyPr>
+          <a:lstStyle/>
+          <a:p>
+            <a:pPr algn="l"/>
+            <a:r>
+              <a:rPr sz="900" b="1" i="0">
+                <a:solidFill>
+                  <a:srgbClr val="C9A84C"/>
+                </a:solidFill>
+                <a:latin typeface="Barlow Condensed"/>
+              </a:rPr>
+              <a:t>PROTOCOL BUILDER</a:t>
+            </a:r>
+          </a:p>
+        </p:txBody>
+      </p:sp>
+      <p:sp>
+        <p:nvSpPr>
+          <p:cNvPr id="31" name="TextBox 30"/>
           <p:cNvSpPr txBox="1"/>
           <p:nvPr/>
         </p:nvSpPr>

</xml_diff>